<commit_message>
Verify live agent on cohere/north-mini-code:free and record live A/B subset
google/gemma-4-31b-it:free returned HTTP 429 upstream on every request, so
with the owner's approval the agent was verified on the free Cohere model.
The live test passes (model-chosen tool calls, real MCP retrieval, Pydantic
and grounding validation). A matched live A/B subset scored 5/6 per
configuration; both fail 13_evidence on grounding, recorded as-is.

Shared prompt now asks for a JSON instance rather than the schema, repair
messages state the validation reason, finish reasons are tracked, and eval
rows record the model. Gemma stays documented as an alternative.

Co-Authored-By: Claude Opus 5.5 <noreply@anthropic.com>
</commit_message>
<xml_diff>
--- a/slides/ReleasePulse-capstone.pptx
+++ b/slides/ReleasePulse-capstone.pptx
@@ -6562,7 +6562,7 @@
                 <a:ea typeface="Arial"/>
                 <a:cs typeface="Arial"/>
               </a:rPr>
-              <a:t>Live AI demonstration requires an OpenRouter key.</a:t>
+              <a:t>Live model: cohere/north-mini-code:free on OpenRouter.</a:t>
             </a:r>
           </a:p>
         </p:txBody>
@@ -8480,7 +8480,7 @@
                 <a:ea typeface="Arial"/>
                 <a:cs typeface="Arial"/>
               </a:rPr>
-              <a:t>38 regression tests passed</a:t>
+              <a:t>40 offline + 1 live test passed</a:t>
             </a:r>
           </a:p>
         </p:txBody>
@@ -8682,7 +8682,7 @@
                 <a:ea typeface="Arial"/>
                 <a:cs typeface="Arial"/>
               </a:rPr>
-              <a:t>Earlier environment failures retained; live model results pending.</a:t>
+              <a:t>Live subset: A 5/6, B 5/6; 11 tasks per config pending quota.</a:t>
             </a:r>
           </a:p>
         </p:txBody>
@@ -9404,7 +9404,7 @@
                 <a:ea typeface="Arial"/>
                 <a:cs typeface="Arial"/>
               </a:rPr>
-              <a:t>Local attack regressions passed; live adversarial testing is pending.</a:t>
+              <a:t>Injection task passed live in A and B (one trial each).</a:t>
             </a:r>
           </a:p>
         </p:txBody>

</xml_diff>